<commit_message>
PDF e PowerPoint atualizados para prova de 2 horas
</commit_message>
<xml_diff>
--- a/Apresentacao-Interativa-ABCDETRAN.pptx
+++ b/Apresentacao-Interativa-ABCDETRAN.pptx
@@ -3140,7 +3140,7 @@
                   <a:srgbClr val="FFFFFF"/>
                 </a:solidFill>
               </a:rPr>
-              <a:t>Guia Pratico: Como Realizar sua Prova ABCDETRAN</a:t>
+              <a:t>Guia Prático: Como Realizar sua Prova ABCDETRAN</a:t>
             </a:r>
           </a:p>
         </p:txBody>
@@ -3174,7 +3174,7 @@
                   <a:srgbClr val="FFFFFF"/>
                 </a:solidFill>
               </a:rPr>
-              <a:t>Auto Escola Quixelo - passo a passo interativo para navegar na prova teorica</a:t>
+              <a:t>Auto Escola Quixelô — passo a passo interativo para navegar na prova teórica</a:t>
             </a:r>
           </a:p>
         </p:txBody>
@@ -3208,7 +3208,7 @@
                   <a:srgbClr val="F5B301"/>
                 </a:solidFill>
               </a:rPr>
-              <a:t>30 questoes  -  1 minuto por questao  -  aprovacao com 70%</a:t>
+              <a:t>30 questões · 2 horas de prova · aprovação com 70%</a:t>
             </a:r>
           </a:p>
         </p:txBody>
@@ -3261,7 +3261,7 @@
                   <a:srgbClr val="FFFFFF"/>
                 </a:solidFill>
               </a:rPr>
-              <a:t>COMECAR -&gt;</a:t>
+              <a:t>COMEÇAR →</a:t>
             </a:r>
           </a:p>
         </p:txBody>
@@ -3321,7 +3321,7 @@
                   <a:srgbClr val="C62828"/>
                 </a:solidFill>
               </a:rPr>
-              <a:t>OPS! Sem confirmar, a questao fica em branco.</a:t>
+              <a:t>OPS! Sem confirmar, a questão fica em branco.</a:t>
             </a:r>
           </a:p>
         </p:txBody>
@@ -3355,7 +3355,7 @@
                   <a:srgbClr val="1E1E1E"/>
                 </a:solidFill>
               </a:rPr>
-              <a:t>Regra laranja: clique no botao LARANJA antes de avancar.</a:t>
+              <a:t>Regra laranja: clique no botão LARANJA antes de avançar.</a:t>
             </a:r>
           </a:p>
         </p:txBody>
@@ -3572,7 +3572,7 @@
                   <a:srgbClr val="1D4A86"/>
                 </a:solidFill>
               </a:rPr>
-              <a:t>Qual e a meta para ser aprovado?</a:t>
+              <a:t>Qual é a meta para ser aprovado?</a:t>
             </a:r>
           </a:p>
         </p:txBody>
@@ -3625,7 +3625,7 @@
                   <a:srgbClr val="FFFFFF"/>
                 </a:solidFill>
               </a:rPr>
-              <a:t>A) 30 questoes e 70% (21 acertos)</a:t>
+              <a:t>A) 30 questões e 70% (21 acertos)</a:t>
             </a:r>
           </a:p>
         </p:txBody>
@@ -3678,7 +3678,7 @@
                   <a:srgbClr val="FFFFFF"/>
                 </a:solidFill>
               </a:rPr>
-              <a:t>B) 20 questoes e 50%</a:t>
+              <a:t>B) 20 questões e 50%</a:t>
             </a:r>
           </a:p>
         </p:txBody>
@@ -3731,7 +3731,7 @@
                   <a:srgbClr val="FFFFFF"/>
                 </a:solidFill>
               </a:rPr>
-              <a:t>C) 10 questoes e 100%</a:t>
+              <a:t>C) 10 questões e 100%</a:t>
             </a:r>
           </a:p>
         </p:txBody>
@@ -3844,7 +3844,7 @@
                   <a:srgbClr val="34A14C"/>
                 </a:solidFill>
               </a:rPr>
-              <a:t>CORRETO! 30 questoes e 70% para aprovar.</a:t>
+              <a:t>CORRETO! 30 questões e 70% para aprovar.</a:t>
             </a:r>
           </a:p>
         </p:txBody>
@@ -3878,7 +3878,7 @@
                   <a:srgbClr val="1E1E1E"/>
                 </a:solidFill>
               </a:rPr>
-              <a:t>Ou seja: acertar pelo menos 21 das 30 questoes.</a:t>
+              <a:t>Ou seja: acertar pelo menos 21 das 30 questões.</a:t>
             </a:r>
           </a:p>
         </p:txBody>
@@ -3931,7 +3931,7 @@
                   <a:srgbClr val="FFFFFF"/>
                 </a:solidFill>
               </a:rPr>
-              <a:t>Ver checklist -&gt;</a:t>
+              <a:t>Ver checklist →</a:t>
             </a:r>
           </a:p>
         </p:txBody>
@@ -4078,7 +4078,7 @@
                   <a:srgbClr val="1E1E1E"/>
                 </a:solidFill>
               </a:rPr>
-              <a:t>Sao 30 questoes obrigatorias e 70% para aprovar.</a:t>
+              <a:t>São 30 questões obrigatórias e 70% para aprovar.</a:t>
             </a:r>
           </a:p>
         </p:txBody>
@@ -4261,7 +4261,7 @@
                   <a:srgbClr val="FFFFFF"/>
                 </a:solidFill>
               </a:rPr>
-              <a:t>  6A. Pendencias bloqueiam a finalizacao</a:t>
+              <a:t>  6A. Pendências bloqueiam a finalização</a:t>
             </a:r>
           </a:p>
         </p:txBody>
@@ -4295,7 +4295,7 @@
                   <a:srgbClr val="C62828"/>
                 </a:solidFill>
               </a:rPr>
-              <a:t>Aviso: Ainda existem questoes a serem resolvidas.</a:t>
+              <a:t>Aviso: Ainda existem questões a serem resolvidas.</a:t>
             </a:r>
           </a:p>
         </p:txBody>
@@ -4333,7 +4333,7 @@
                   <a:srgbClr val="1E1E1E"/>
                 </a:solidFill>
               </a:rPr>
-              <a:t>1. RETORNE - volte ate a questao indicada.</a:t>
+              <a:t>1. RETORNE — volte até a questão indicada.</a:t>
             </a:r>
           </a:p>
           <a:p>
@@ -4348,7 +4348,7 @@
                   <a:srgbClr val="1E1E1E"/>
                 </a:solidFill>
               </a:rPr>
-              <a:t>2. MARQUE - selecione o quadrado da alternativa.</a:t>
+              <a:t>2. MARQUE — selecione o quadrado da alternativa.</a:t>
             </a:r>
           </a:p>
           <a:p>
@@ -4363,7 +4363,7 @@
                   <a:srgbClr val="1E1E1E"/>
                 </a:solidFill>
               </a:rPr>
-              <a:t>3. GRAVE - confirme no LARANJA (OK).</a:t>
+              <a:t>3. GRAVE — confirme no LARANJA (✓).</a:t>
             </a:r>
           </a:p>
           <a:p>
@@ -4378,7 +4378,7 @@
                   <a:srgbClr val="1E1E1E"/>
                 </a:solidFill>
               </a:rPr>
-              <a:t>4. SIGA - avance no AZUL (&gt;).</a:t>
+              <a:t>4. SIGA — avance no AZUL (›).</a:t>
             </a:r>
           </a:p>
         </p:txBody>
@@ -4484,7 +4484,7 @@
                   <a:srgbClr val="FFFFFF"/>
                 </a:solidFill>
               </a:rPr>
-              <a:t>AVANCAR &gt;</a:t>
+              <a:t>AVANÇAR ›</a:t>
             </a:r>
           </a:p>
         </p:txBody>
@@ -4599,7 +4599,7 @@
                   <a:srgbClr val="1E1E1E"/>
                 </a:solidFill>
               </a:rPr>
-              <a:t>- Teclado: so numeros da tela, sem tracos/pontos.</a:t>
+              <a:t>— Teclado: só números da tela, sem traços/pontos.</a:t>
             </a:r>
           </a:p>
           <a:p>
@@ -4614,7 +4614,7 @@
                   <a:srgbClr val="1E1E1E"/>
                 </a:solidFill>
               </a:rPr>
-              <a:t>- Meta: completar as 30 questoes.</a:t>
+              <a:t>— Meta: completar as 30 questões.</a:t>
             </a:r>
           </a:p>
           <a:p>
@@ -4629,7 +4629,7 @@
                   <a:srgbClr val="1E1E1E"/>
                 </a:solidFill>
               </a:rPr>
-              <a:t>- Visual: quadrado com borda pontilhada preta.</a:t>
+              <a:t>— Visual: quadrado com borda pontilhada preta.</a:t>
             </a:r>
           </a:p>
           <a:p>
@@ -4644,7 +4644,7 @@
                   <a:srgbClr val="1E1E1E"/>
                 </a:solidFill>
               </a:rPr>
-              <a:t>- Regra laranja: nunca avance sem confirmar.</a:t>
+              <a:t>— Regra laranja: nunca avance sem confirmar.</a:t>
             </a:r>
           </a:p>
           <a:p>
@@ -4659,7 +4659,7 @@
                   <a:srgbClr val="1E1E1E"/>
                 </a:solidFill>
               </a:rPr>
-              <a:t>- Conclusao: tela 'Disciplina concluida!' &gt;&gt;.</a:t>
+              <a:t>— Conclusão: tela 'Disciplina concluída!' ».</a:t>
             </a:r>
           </a:p>
           <a:p>
@@ -4674,7 +4674,7 @@
                   <a:srgbClr val="1E1E1E"/>
                 </a:solidFill>
               </a:rPr>
-              <a:t>- Tempo: 1 minuto por questao.</a:t>
+              <a:t>— Tempo: 2 horas de prova.</a:t>
             </a:r>
           </a:p>
         </p:txBody>
@@ -4840,7 +4840,7 @@
                   <a:srgbClr val="FFFFFF"/>
                 </a:solidFill>
               </a:rPr>
-              <a:t>Boa prova! Voce esta pronto.</a:t>
+              <a:t>Boa prova! Você está pronto.</a:t>
             </a:r>
           </a:p>
         </p:txBody>
@@ -4874,7 +4874,7 @@
                   <a:srgbClr val="FFFFFF"/>
                 </a:solidFill>
               </a:rPr>
-              <a:t>Ciclo de ouro: Selecionar -&gt; Confirmar -&gt; Avancar (30 vezes).</a:t>
+              <a:t>Ciclo de ouro: Selecionar → Confirmar → Avançar (30 vezes).</a:t>
             </a:r>
           </a:p>
         </p:txBody>
@@ -4908,7 +4908,7 @@
                   <a:srgbClr val="F5B301"/>
                 </a:solidFill>
               </a:rPr>
-              <a:t>Apresentacao interativa - use os botoes para navegar e refazer o quiz.</a:t>
+              <a:t>Apresentação interativa — use os botões para navegar e refazer o quiz.</a:t>
             </a:r>
           </a:p>
         </p:txBody>
@@ -4961,7 +4961,7 @@
                   <a:srgbClr val="FFFFFF"/>
                 </a:solidFill>
               </a:rPr>
-              <a:t>RECOMECAR</a:t>
+              <a:t>RECOMEÇAR</a:t>
             </a:r>
           </a:p>
         </p:txBody>
@@ -5091,7 +5091,7 @@
                   <a:srgbClr val="FFFFFF"/>
                 </a:solidFill>
               </a:rPr>
-              <a:t>  MENU INTERATIVO - clique em uma opcao</a:t>
+              <a:t>  MENU INTERATIVO — clique em uma opção</a:t>
             </a:r>
           </a:p>
         </p:txBody>
@@ -5125,7 +5125,7 @@
                   <a:srgbClr val="6B7280"/>
                 </a:solidFill>
               </a:rPr>
-              <a:t>Escolha por onde comecar. Os botoes saltam direto para o assunto.</a:t>
+              <a:t>Escolha por onde começar. Os botões saltam direto para o assunto.</a:t>
             </a:r>
           </a:p>
         </p:txBody>
@@ -5231,7 +5231,7 @@
                   <a:srgbClr val="FFFFFF"/>
                 </a:solidFill>
               </a:rPr>
-              <a:t>2. Os 3 botoes do sistema</a:t>
+              <a:t>2. Os 3 botões do sistema</a:t>
             </a:r>
           </a:p>
         </p:txBody>
@@ -5443,7 +5443,7 @@
                   <a:srgbClr val="FFFFFF"/>
                 </a:solidFill>
               </a:rPr>
-              <a:t>6. Pendencias e checklist</a:t>
+              <a:t>6. Pendências e checklist</a:t>
             </a:r>
           </a:p>
         </p:txBody>
@@ -5477,7 +5477,7 @@
                   <a:srgbClr val="6B7280"/>
                 </a:solidFill>
               </a:rPr>
-              <a:t>Dica: em todas as telas ha botoes MENU, VOLTAR e AVANCAR clicaveis.</a:t>
+              <a:t>Dica: em todas as telas há botões MENU, VOLTAR e AVANÇAR clicáveis.</a:t>
             </a:r>
           </a:p>
         </p:txBody>
@@ -5554,7 +5554,7 @@
                   <a:srgbClr val="FFFFFF"/>
                 </a:solidFill>
               </a:rPr>
-              <a:t>  1. O Caminho da Aprovacao em 5 Etapas</a:t>
+              <a:t>  1. O Caminho da Aprovação em 5 Etapas</a:t>
             </a:r>
           </a:p>
         </p:txBody>
@@ -5592,7 +5592,7 @@
                   <a:srgbClr val="1E1E1E"/>
                 </a:solidFill>
               </a:rPr>
-              <a:t>1. ACESSO - login com CPF no teclado virtual.</a:t>
+              <a:t>1. ACESSO — login com CPF no teclado virtual.</a:t>
             </a:r>
           </a:p>
           <a:p>
@@ -5607,7 +5607,7 @@
                   <a:srgbClr val="1E1E1E"/>
                 </a:solidFill>
               </a:rPr>
-              <a:t>2. CADERNO - selecao da prova (Caderno N. 01 / Tipo: SIMULADO).</a:t>
+              <a:t>2. CADERNO — seleção da prova (Caderno Nº 01 / Tipo: SIMULADO).</a:t>
             </a:r>
           </a:p>
           <a:p>
@@ -5622,7 +5622,7 @@
                   <a:srgbClr val="1E1E1E"/>
                 </a:solidFill>
               </a:rPr>
-              <a:t>3. RESOLUCAO - leitura do enunciado e marcacao da alternativa.</a:t>
+              <a:t>3. RESOLUÇÃO — leitura do enunciado e marcação da alternativa.</a:t>
             </a:r>
           </a:p>
           <a:p>
@@ -5637,7 +5637,7 @@
                   <a:srgbClr val="1E1E1E"/>
                 </a:solidFill>
               </a:rPr>
-              <a:t>4. REVISAO - verificacao de pendencias (o sistema bloqueia a finalizacao).</a:t>
+              <a:t>4. REVISÃO — verificação de pendências (o sistema bloqueia a finalização).</a:t>
             </a:r>
           </a:p>
           <a:p>
@@ -5652,7 +5652,7 @@
                   <a:srgbClr val="1E1E1E"/>
                 </a:solidFill>
               </a:rPr>
-              <a:t>5. CONCLUSAO - tela 'Disciplina concluida!' com nota e gabarito.</a:t>
+              <a:t>5. CONCLUSÃO — tela 'Disciplina concluída!' com nota e gabarito.</a:t>
             </a:r>
           </a:p>
         </p:txBody>
@@ -5758,7 +5758,7 @@
                   <a:srgbClr val="FFFFFF"/>
                 </a:solidFill>
               </a:rPr>
-              <a:t>AVANCAR &gt;</a:t>
+              <a:t>AVANÇAR ›</a:t>
             </a:r>
           </a:p>
         </p:txBody>
@@ -5835,7 +5835,7 @@
                   <a:srgbClr val="FFFFFF"/>
                 </a:solidFill>
               </a:rPr>
-              <a:t>  2. O Idioma do Sistema: os 3 Botoes</a:t>
+              <a:t>  2. O Idioma do Sistema: os 3 Botões</a:t>
             </a:r>
           </a:p>
         </p:txBody>
@@ -5886,16 +5886,16 @@
                   <a:srgbClr val="FFFFFF"/>
                 </a:solidFill>
               </a:rPr>
-              <a:t>VERDE  -&gt;</a:t>
+              <a:t>VERDE  →</a:t>
             </a:r>
             <a:br/>
             <a:r>
-              <a:t>Entrar / Confirmar Inicio</a:t>
+              <a:t>Entrar / Confirmar Início</a:t>
             </a:r>
             <a:br/>
             <a:br/>
             <a:r>
-              <a:t>So para acessar no inicio</a:t>
+              <a:t>Só para acessar no início</a:t>
             </a:r>
           </a:p>
         </p:txBody>
@@ -5946,7 +5946,7 @@
                   <a:srgbClr val="FFFFFF"/>
                 </a:solidFill>
               </a:rPr>
-              <a:t>LARANJA  OK</a:t>
+              <a:t>LARANJA  ✓</a:t>
             </a:r>
             <a:br/>
             <a:r>
@@ -6006,16 +6006,16 @@
                   <a:srgbClr val="FFFFFF"/>
                 </a:solidFill>
               </a:rPr>
-              <a:t>AZUL  &gt;</a:t>
+              <a:t>AZUL  ›</a:t>
             </a:r>
             <a:br/>
             <a:r>
-              <a:t>Avancar</a:t>
+              <a:t>Avançar</a:t>
             </a:r>
             <a:br/>
             <a:br/>
             <a:r>
-              <a:t>Vai para a proxima</a:t>
+              <a:t>Vai para a próxima</a:t>
             </a:r>
           </a:p>
         </p:txBody>
@@ -6049,7 +6049,7 @@
                   <a:srgbClr val="B95F0E"/>
                 </a:solidFill>
               </a:rPr>
-              <a:t>LARANJA + AZUL = dupla inseparavel: confirme primeiro, depois avance.</a:t>
+              <a:t>LARANJA + AZUL = dupla inseparável: confirme primeiro, depois avance.</a:t>
             </a:r>
           </a:p>
         </p:txBody>
@@ -6155,7 +6155,7 @@
                   <a:srgbClr val="FFFFFF"/>
                 </a:solidFill>
               </a:rPr>
-              <a:t>AVANCAR &gt;</a:t>
+              <a:t>AVANÇAR ›</a:t>
             </a:r>
           </a:p>
         </p:txBody>
@@ -6232,7 +6232,7 @@
                   <a:srgbClr val="FFFFFF"/>
                 </a:solidFill>
               </a:rPr>
-              <a:t>  3A. Passo 1: Identificacao por CPF</a:t>
+              <a:t>  3A. Passo 1: Identificação por CPF</a:t>
             </a:r>
           </a:p>
         </p:txBody>
@@ -6270,7 +6270,7 @@
                   <a:srgbClr val="1E1E1E"/>
                 </a:solidFill>
               </a:rPr>
-              <a:t>- Digite os 11 algarismos no TECLADO VIRTUAL da tela.</a:t>
+              <a:t>— Digite os 11 algarismos no TECLADO VIRTUAL da tela.</a:t>
             </a:r>
           </a:p>
           <a:p>
@@ -6285,7 +6285,7 @@
                   <a:srgbClr val="1E1E1E"/>
                 </a:solidFill>
               </a:rPr>
-              <a:t>- Sem pontos e sem tracos. Apenas numeros.</a:t>
+              <a:t>— Sem pontos e sem traços. Apenas números.</a:t>
             </a:r>
           </a:p>
           <a:p>
@@ -6300,7 +6300,7 @@
                   <a:srgbClr val="1E1E1E"/>
                 </a:solidFill>
               </a:rPr>
-              <a:t>- Tecla LARANJA (&lt;&lt;) apaga. Seta VERDE (-&gt;) entra.</a:t>
+              <a:t>— Tecla LARANJA («) apaga. Seta VERDE (→) entra.</a:t>
             </a:r>
           </a:p>
           <a:p>
@@ -6315,7 +6315,7 @@
                   <a:srgbClr val="1E1E1E"/>
                 </a:solidFill>
               </a:rPr>
-              <a:t>- CPF de teste: 111.111.111-11.</a:t>
+              <a:t>— CPF de teste: 111.111.111-11.</a:t>
             </a:r>
           </a:p>
         </p:txBody>
@@ -6421,7 +6421,7 @@
                   <a:srgbClr val="FFFFFF"/>
                 </a:solidFill>
               </a:rPr>
-              <a:t>AVANCAR &gt;</a:t>
+              <a:t>AVANÇAR ›</a:t>
             </a:r>
           </a:p>
         </p:txBody>
@@ -6536,7 +6536,7 @@
                   <a:srgbClr val="1E1E1E"/>
                 </a:solidFill>
               </a:rPr>
-              <a:t>- Confira NOME, TURMA, ultimo acesso e IP no topo.</a:t>
+              <a:t>— Confira NOME, TURMA, último acesso e IP no topo.</a:t>
             </a:r>
           </a:p>
           <a:p>
@@ -6551,7 +6551,7 @@
                   <a:srgbClr val="1E1E1E"/>
                 </a:solidFill>
               </a:rPr>
-              <a:t>- Clique no cartao: Caderno N. 01 / Tipo: SIMULADO.</a:t>
+              <a:t>— Clique no cartão: Caderno Nº 01 / Tipo: SIMULADO.</a:t>
             </a:r>
           </a:p>
           <a:p>
@@ -6566,7 +6566,7 @@
                   <a:srgbClr val="1E1E1E"/>
                 </a:solidFill>
               </a:rPr>
-              <a:t>- Botao ACESSAR O CADERNO inicia a prova.</a:t>
+              <a:t>— Botão ACESSAR O CADERNO inicia a prova.</a:t>
             </a:r>
           </a:p>
           <a:p>
@@ -6581,7 +6581,7 @@
                   <a:srgbClr val="1E1E1E"/>
                 </a:solidFill>
               </a:rPr>
-              <a:t>- Topo da prova: QUESTAO X/30, progresso e cronometro.</a:t>
+              <a:t>— Topo da prova: QUESTÃO X/30, progresso e cronômetro de 2 horas.</a:t>
             </a:r>
           </a:p>
         </p:txBody>
@@ -6687,7 +6687,7 @@
                   <a:srgbClr val="FFFFFF"/>
                 </a:solidFill>
               </a:rPr>
-              <a:t>AVANCAR &gt;</a:t>
+              <a:t>AVANÇAR ›</a:t>
             </a:r>
           </a:p>
         </p:txBody>
@@ -6764,7 +6764,7 @@
                   <a:srgbClr val="FFFFFF"/>
                 </a:solidFill>
               </a:rPr>
-              <a:t>  4. A Regra de Ouro: 3 Passos por Questao</a:t>
+              <a:t>  4. A Regra de Ouro: 3 Passos por Questão</a:t>
             </a:r>
           </a:p>
         </p:txBody>
@@ -6802,7 +6802,7 @@
                   <a:srgbClr val="1E1E1E"/>
                 </a:solidFill>
               </a:rPr>
-              <a:t>Passo 1 - SELECIONAR: clique no quadrado. A borda fica PRETA e PONTILHADA.</a:t>
+              <a:t>Passo 1 — SELECIONAR: clique no quadrado. A borda fica PRETA e PONTILHADA.</a:t>
             </a:r>
           </a:p>
           <a:p>
@@ -6817,7 +6817,7 @@
                   <a:srgbClr val="1E1E1E"/>
                 </a:solidFill>
               </a:rPr>
-              <a:t>Passo 2 - CONFIRMAR: botao LARANJA (OK). Sem isso, a questao nao conta!</a:t>
+              <a:t>Passo 2 — CONFIRMAR: botão LARANJA (✓). Sem isso, a questão não conta!</a:t>
             </a:r>
           </a:p>
           <a:p>
@@ -6832,7 +6832,7 @@
                   <a:srgbClr val="1E1E1E"/>
                 </a:solidFill>
               </a:rPr>
-              <a:t>Passo 3 - AVANCAR: botao AZUL (&gt;) para a proxima pergunta.</a:t>
+              <a:t>Passo 3 — AVANÇAR: botão AZUL (›) para a próxima pergunta.</a:t>
             </a:r>
           </a:p>
           <a:p>
@@ -6953,7 +6953,7 @@
                   <a:srgbClr val="FFFFFF"/>
                 </a:solidFill>
               </a:rPr>
-              <a:t>IR PARA O QUIZ -&gt;</a:t>
+              <a:t>IR PARA O QUIZ →</a:t>
             </a:r>
           </a:p>
         </p:txBody>
@@ -7030,7 +7030,7 @@
                   <a:srgbClr val="FFFFFF"/>
                 </a:solidFill>
               </a:rPr>
-              <a:t>  5A. QUIZ: voce decide!</a:t>
+              <a:t>  5A. QUIZ: você decide!</a:t>
             </a:r>
           </a:p>
         </p:txBody>
@@ -7064,7 +7064,7 @@
                   <a:srgbClr val="1D4A86"/>
                 </a:solidFill>
               </a:rPr>
-              <a:t>Voce SELECIONOU a alternativa (borda pontilhada). O que fazer agora?</a:t>
+              <a:t>Você SELECIONOU a alternativa (borda pontilhada). O que fazer agora?</a:t>
             </a:r>
           </a:p>
         </p:txBody>
@@ -7117,7 +7117,7 @@
                   <a:srgbClr val="FFFFFF"/>
                 </a:solidFill>
               </a:rPr>
-              <a:t>A) Avancar direto no AZUL</a:t>
+              <a:t>A) Avançar direto no AZUL</a:t>
             </a:r>
           </a:p>
         </p:txBody>
@@ -7170,7 +7170,7 @@
                   <a:srgbClr val="FFFFFF"/>
                 </a:solidFill>
               </a:rPr>
-              <a:t>B) Confirmar no LARANJA (OK)</a:t>
+              <a:t>B) Confirmar no LARANJA (✓)</a:t>
             </a:r>
           </a:p>
         </p:txBody>
@@ -7336,7 +7336,7 @@
                   <a:srgbClr val="34A14C"/>
                 </a:solidFill>
               </a:rPr>
-              <a:t>CORRETO! Voce confirmou no LARANJA.</a:t>
+              <a:t>CORRETO! Você confirmou no LARANJA.</a:t>
             </a:r>
           </a:p>
         </p:txBody>
@@ -7370,7 +7370,7 @@
                   <a:srgbClr val="1E1E1E"/>
                 </a:solidFill>
               </a:rPr>
-              <a:t>E o ciclo certo: Selecionar -&gt; Confirmar -&gt; Avancar.</a:t>
+              <a:t>É o ciclo certo: Selecionar → Confirmar → Avançar.</a:t>
             </a:r>
           </a:p>
         </p:txBody>
@@ -7423,7 +7423,7 @@
                   <a:srgbClr val="FFFFFF"/>
                 </a:solidFill>
               </a:rPr>
-              <a:t>Proxima pergunta -&gt;</a:t>
+              <a:t>Próxima pergunta →</a:t>
             </a:r>
           </a:p>
         </p:txBody>

</xml_diff>